<commit_message>
Updated standup notes to include our kanban snapshots
</commit_message>
<xml_diff>
--- a/Docs/team-5/SubTeam5_Overview.pptx
+++ b/Docs/team-5/SubTeam5_Overview.pptx
@@ -1607,7 +1607,7 @@
           <a:bodyPr wrap="square" lIns="0" tIns="0" rIns="0" bIns="0" rtlCol="0" anchor="ctr"/>
           <a:lstStyle/>
           <a:p>
-            <a:pPr marL="0" indent="0">
+            <a:pPr marL="0" indent="0" algn="ctr">
               <a:buNone/>
             </a:pPr>
             <a:r>
@@ -1646,7 +1646,7 @@
           <a:bodyPr wrap="square" lIns="0" tIns="0" rIns="0" bIns="0" rtlCol="0" anchor="ctr"/>
           <a:lstStyle/>
           <a:p>
-            <a:pPr marL="0" indent="0">
+            <a:pPr marL="0" indent="0" algn="ctr">
               <a:buNone/>
             </a:pPr>
             <a:r>
@@ -1692,7 +1692,8 @@
           <a:bodyPr/>
           <a:lstStyle/>
           <a:p>
-            <a:endParaRPr lang="en-IE"/>
+            <a:pPr algn="ctr"/>
+            <a:endParaRPr lang="en-IE" dirty="0"/>
           </a:p>
         </p:txBody>
       </p:sp>
@@ -2417,7 +2418,7 @@
           <a:bodyPr wrap="square" lIns="0" tIns="0" rIns="0" bIns="0" rtlCol="0" anchor="ctr"/>
           <a:lstStyle/>
           <a:p>
-            <a:pPr marL="0" indent="0">
+            <a:pPr marL="0" indent="0" algn="ctr">
               <a:buNone/>
             </a:pPr>
             <a:r>
@@ -2456,7 +2457,7 @@
           <a:bodyPr wrap="square" lIns="0" tIns="0" rIns="0" bIns="0" rtlCol="0" anchor="ctr"/>
           <a:lstStyle/>
           <a:p>
-            <a:pPr marL="0" indent="0">
+            <a:pPr marL="0" indent="0" algn="ctr">
               <a:buNone/>
             </a:pPr>
             <a:r>

</xml_diff>